<commit_message>
Final MIPLIB sweep (33/64 proven optimal in 60 s, HiGHS 47, no wrong optima); report and deck regenerated
Deck: quoted-field CSV parsing (QP count now matches the report), presolve layer marked built.
</commit_message>
<xml_diff>
--- a/deliverables/deck/ZeroCloud_SIH26119_NIRNAY.pptx
+++ b/deliverables/deck/ZeroCloud_SIH26119_NIRNAY.pptx
@@ -138,7 +138,7 @@
                 </a:solidFill>
                 <a:latin typeface="Arial"/>
               </a:rPr>
-              <a:t>Netlib LP collection (90 problems)</a:t>
+              <a:t>Problems solved to the reference optimum (%)</a:t>
             </a:r>
           </a:p>
         </c:rich>
@@ -162,7 +162,7 @@
               <c:strCache>
                 <c:ptCount val="1"/>
                 <c:pt idx="0">
-                  <c:v>Solved</c:v>
+                  <c:v>NIRNAY</c:v>
                 </c:pt>
               </c:strCache>
             </c:strRef>
@@ -175,13 +175,13 @@
           </c:spPr>
           <c:invertIfNegative val="0"/>
           <c:dLbls>
-            <c:numFmt formatCode="#,##0" sourceLinked="0"/>
+            <c:numFmt formatCode="0&quot;%&quot;" sourceLinked="0"/>
             <c:txPr>
               <a:bodyPr/>
               <a:lstStyle/>
               <a:p>
                 <a:pPr>
-                  <a:defRPr b="0" i="0" strike="noStrike" sz="1200" u="none">
+                  <a:defRPr b="0" i="0" strike="noStrike" sz="1100" u="none">
                     <a:solidFill>
                       <a:srgbClr val="2B2F36"/>
                     </a:solidFill>
@@ -198,67 +198,20 @@
             <c:showBubbleSize val="0"/>
             <c:showLeaderLines val="0"/>
           </c:dLbls>
-          <c:dPt>
-            <c:idx val="0"/>
-            <c:invertIfNegative val="0"/>
-            <c:bubble3D val="0"/>
-            <c:spPr>
-              <a:solidFill>
-                <a:srgbClr val="E8702A"/>
-              </a:solidFill>
-              <a:effectLst/>
-            </c:spPr>
-          </c:dPt>
-          <c:dPt>
-            <c:idx val="1"/>
-            <c:invertIfNegative val="0"/>
-            <c:bubble3D val="0"/>
-            <c:spPr>
-              <a:solidFill>
-                <a:srgbClr val="1F2A44"/>
-              </a:solidFill>
-              <a:effectLst/>
-            </c:spPr>
-          </c:dPt>
-          <c:dPt>
-            <c:idx val="2"/>
-            <c:invertIfNegative val="0"/>
-            <c:bubble3D val="0"/>
-            <c:spPr>
-              <a:solidFill>
-                <a:srgbClr val="1E8C45"/>
-              </a:solidFill>
-              <a:effectLst/>
-            </c:spPr>
-          </c:dPt>
-          <c:dPt>
-            <c:idx val="3"/>
-            <c:invertIfNegative val="0"/>
-            <c:bubble3D val="0"/>
-            <c:spPr>
-              <a:solidFill>
-                <a:srgbClr val="9AA5B1"/>
-              </a:solidFill>
-              <a:effectLst/>
-            </c:spPr>
-          </c:dPt>
           <c:cat>
             <c:multiLvlStrRef>
-              <c:f>Sheet1!$A$2:$A$5</c:f>
+              <c:f>Sheet1!$A$2:$A$4</c:f>
               <c:multiLvlStrCache>
-                <c:ptCount val="4"/>
+                <c:ptCount val="3"/>
                 <c:lvl>
                   <c:pt idx="0">
-                    <c:v>Interior point</c:v>
+                    <c:v>Netlib LP (90)</c:v>
                   </c:pt>
                   <c:pt idx="1">
-                    <c:v>Dual simplex</c:v>
+                    <c:v>MIPLIB 3, 60 s (64)</c:v>
                   </c:pt>
                   <c:pt idx="2">
-                    <c:v>Either engine</c:v>
-                  </c:pt>
-                  <c:pt idx="3">
-                    <c:v>HiGHS (reference)</c:v>
+                    <c:v>Maros–Mészáros QP (138)</c:v>
                   </c:pt>
                 </c:lvl>
               </c:multiLvlStrCache>
@@ -266,34 +219,114 @@
           </c:cat>
           <c:val>
             <c:numRef>
-              <c:f>Sheet1!$B$2:$B$5</c:f>
+              <c:f>Sheet1!$B$2:$B$4</c:f>
               <c:numCache>
                 <c:formatCode>General</c:formatCode>
-                <c:ptCount val="4"/>
+                <c:ptCount val="3"/>
                 <c:pt idx="0">
-                  <c:v>86</c:v>
+                  <c:v>100</c:v>
                 </c:pt>
                 <c:pt idx="1">
-                  <c:v>82</c:v>
+                  <c:v>51.6</c:v>
                 </c:pt>
                 <c:pt idx="2">
-                  <c:v>88</c:v>
+                  <c:v>87.7</c:v>
                 </c:pt>
-                <c:pt idx="3">
-                  <c:v>90</c:v>
+              </c:numCache>
+            </c:numRef>
+          </c:val>
+        </c:ser>
+        <c:ser>
+          <c:idx val="1"/>
+          <c:order val="1"/>
+          <c:tx>
+            <c:strRef>
+              <c:f>Sheet1!$C$1</c:f>
+              <c:strCache>
+                <c:ptCount val="1"/>
+                <c:pt idx="0">
+                  <c:v>Reference (HiGHS / Clarabel)</c:v>
+                </c:pt>
+              </c:strCache>
+            </c:strRef>
+          </c:tx>
+          <c:spPr>
+            <a:solidFill>
+              <a:srgbClr val="9AA5B1"/>
+            </a:solidFill>
+            <a:effectLst/>
+          </c:spPr>
+          <c:invertIfNegative val="0"/>
+          <c:dLbls>
+            <c:numFmt formatCode="0&quot;%&quot;" sourceLinked="0"/>
+            <c:txPr>
+              <a:bodyPr/>
+              <a:lstStyle/>
+              <a:p>
+                <a:pPr>
+                  <a:defRPr b="0" i="0" strike="noStrike" sz="1100" u="none">
+                    <a:solidFill>
+                      <a:srgbClr val="2B2F36"/>
+                    </a:solidFill>
+                    <a:latin typeface="Arial"/>
+                  </a:defRPr>
+                </a:pPr>
+              </a:p>
+            </c:txPr>
+            <c:showLegendKey val="0"/>
+            <c:showVal val="1"/>
+            <c:showCatName val="0"/>
+            <c:showSerName val="0"/>
+            <c:showPercent val="0"/>
+            <c:showBubbleSize val="0"/>
+            <c:showLeaderLines val="0"/>
+          </c:dLbls>
+          <c:cat>
+            <c:multiLvlStrRef>
+              <c:f>Sheet1!$A$2:$A$4</c:f>
+              <c:multiLvlStrCache>
+                <c:ptCount val="3"/>
+                <c:lvl>
+                  <c:pt idx="0">
+                    <c:v>Netlib LP (90)</c:v>
+                  </c:pt>
+                  <c:pt idx="1">
+                    <c:v>MIPLIB 3, 60 s (64)</c:v>
+                  </c:pt>
+                  <c:pt idx="2">
+                    <c:v>Maros–Mészáros QP (138)</c:v>
+                  </c:pt>
+                </c:lvl>
+              </c:multiLvlStrCache>
+            </c:multiLvlStrRef>
+          </c:cat>
+          <c:val>
+            <c:numRef>
+              <c:f>Sheet1!$C$2:$C$4</c:f>
+              <c:numCache>
+                <c:formatCode>General</c:formatCode>
+                <c:ptCount val="3"/>
+                <c:pt idx="0">
+                  <c:v>100</c:v>
+                </c:pt>
+                <c:pt idx="1">
+                  <c:v>73.4</c:v>
+                </c:pt>
+                <c:pt idx="2">
+                  <c:v>88.4</c:v>
                 </c:pt>
               </c:numCache>
             </c:numRef>
           </c:val>
         </c:ser>
         <c:dLbls>
-          <c:numFmt formatCode="#,##0" sourceLinked="0"/>
+          <c:numFmt formatCode="0&quot;%&quot;" sourceLinked="0"/>
           <c:txPr>
             <a:bodyPr/>
             <a:lstStyle/>
             <a:p>
               <a:pPr>
-                <a:defRPr b="0" i="0" strike="noStrike" sz="1200" u="none">
+                <a:defRPr b="0" i="0" strike="noStrike" sz="1100" u="none">
                   <a:solidFill>
                     <a:srgbClr val="2B2F36"/>
                   </a:solidFill>
@@ -319,7 +352,7 @@
       <c:catAx>
         <c:axId val="2094734554"/>
         <c:scaling>
-          <c:orientation val="minMax"/>
+          <c:orientation val="maxMin"/>
         </c:scaling>
         <c:delete val="0"/>
         <c:axPos val="l"/>
@@ -341,7 +374,7 @@
           <a:lstStyle/>
           <a:p>
             <a:pPr>
-              <a:defRPr sz="1200" b="0" i="0" u="none" strike="noStrike">
+              <a:defRPr sz="1100" b="0" i="0" u="none" strike="noStrike">
                 <a:solidFill>
                   <a:srgbClr val="2B2F36"/>
                 </a:solidFill>
@@ -361,22 +394,11 @@
         <c:axId val="2094734552"/>
         <c:scaling>
           <c:orientation val="minMax"/>
-          <c:max val="100"/>
+          <c:max val="115"/>
           <c:min val="0"/>
         </c:scaling>
-        <c:delete val="0"/>
+        <c:delete val="1"/>
         <c:axPos val="b"/>
-        <c:majorGridlines>
-          <c:spPr>
-            <a:ln w="6350" cap="flat">
-              <a:solidFill>
-                <a:srgbClr val="E5E8EC"/>
-              </a:solidFill>
-              <a:prstDash val="solid"/>
-              <a:round/>
-            </a:ln>
-          </c:spPr>
-        </c:majorGridlines>
         <c:numFmt formatCode="General" sourceLinked="0"/>
         <c:majorTickMark val="out"/>
         <c:minorTickMark val="none"/>
@@ -397,7 +419,7 @@
             <a:pPr>
               <a:defRPr sz="1200" b="0" i="0" u="none" strike="noStrike">
                 <a:solidFill>
-                  <a:srgbClr val="5B6770"/>
+                  <a:srgbClr val="000000"/>
                 </a:solidFill>
                 <a:latin typeface="Arial"/>
               </a:defRPr>
@@ -417,6 +439,20 @@
         <a:effectLst/>
       </c:spPr>
     </c:plotArea>
+    <c:legend>
+      <c:legendPos val="b"/>
+      <c:overlay val="0"/>
+      <c:txPr>
+        <a:bodyPr/>
+        <a:lstStyle/>
+        <a:p>
+          <a:pPr>
+            <a:defRPr sz="1000">      </a:defRPr>
+          </a:pPr>
+          <a:endParaRPr lang="en-US"/>
+        </a:p>
+      </c:txPr>
+    </c:legend>
     <c:plotVisOnly val="1"/>
     <c:dispBlanksAs val="span"/>
   </c:chart>
@@ -919,7 +955,8 @@
             <a:r>
               <a:rPr lang="en-US" dirty="0"/>
               <a:t>THE IDEA (60s). Start from the dependency, not the code: every refinery plan and blend in India runs through CPLEX, Gurobi or Xpress. Recurring cost, and nobody here can see inside.
-Then the proof it is real: our interior point already solves 86 of the 90 Netlib LPs to the known optimum, and 88 are solved by at least one of our engines. No solver library is inside; the LU and Cholesky factorisations are ours.
+Then the proof it is real: our dual simplex solves all 90 of the 90 Netlib LPs to the known optimum, branch-and-bound proves 33 of 64 MIPLIB 3 problems optimal in 60 seconds, and the QP interior point solves 121 of 138 Maros–Mészáros QPs. No solver library is inside; the LU, Cholesky and LDLᵀ factorisations are ours.
+If asked about speed: on Netlib the dual simplex is 3.7x slower than HiGHS in shifted geometric mean; the kernels are compiled but the iteration loop is still Python, and that is the next piece of work.
 Land the four claims briefly. Spend the time on the first: we do not pick one algorithm, we ship three, because simplex, interior point and GPU PDLP each win on different problems, and a sovereign solver must not be weak where MRPL's models live.</a:t>
             </a:r>
             <a:endParaRPr lang="en-US" dirty="0"/>
@@ -1011,7 +1048,8 @@
               <a:t>TECHNICAL APPROACH (75s). Walk the stack top to bottom, one sentence each.
 The point to land: the problem statement forbids building on an existing solver, so the three places where solvers usually borrow code are the ones we wrote ourselves: the sparse LU under the simplex, the sparse Cholesky under the interior point, and the orderings that keep both sparse.
 Then why three LP engines: simplex gives an exact vertex and warm starts, which branch-and-bound needs; interior point is the most reliable on big sparse LPs; PDLP needs only matrix-vector products, which is exactly what a GPU is good at. The published evidence (cuPDLP, Lu &amp; Yang 2023) is that GPU first-order methods win on very large LPs at moderate accuracy and lose at high accuracy, so we keep all three.
-Close on verification: every benchmark run is re-solved by HiGHS as the reference.</a:t>
+Close on verification: every benchmark run is re-solved by a reference solver (HiGHS for LP and MILP, Clarabel for QP).
+Status, if asked: the green BUILT chips run today and are benchmarked. Presolve covers the classic reductions with an exact dual postsolve; doubleton, dominated-column and parallel-row reductions come next.</a:t>
             </a:r>
             <a:endParaRPr lang="en-US" dirty="0"/>
           </a:p>
@@ -1099,7 +1137,7 @@
           <a:p>
             <a:r>
               <a:rPr lang="en-US" dirty="0"/>
-              <a:t>FEASIBILITY (45s). Lead with the chart: this is measured, not planned. Interior point 86 of 90 Netlib LPs at the known optimum, dual simplex 82 of 87 run so far, 88 solved by at least one engine. Every value is checked against HiGHS.
+              <a:t>FEASIBILITY (45s). Lead with the chart: this is measured, not planned. Dual simplex 90 of 90 Netlib LPs; branch-and-bound 33 of 64 MIPLIB 3 problems proven optimal in 60 seconds where HiGHS proves 47; QP interior point 121 of 138 Maros–Mészáros problems where Clarabel solves 122. Every value is checked against the reference.
 Then two risks only: hard MIPLIB instances (we report the proven gap honestly and close it with cuts) and speed against C++ solvers (the hot loops are compiled native code). Say the others are on the slide.
 If asked whether students can build a solver: the algorithms are published mathematics; the work is careful implementation and testing, which is what this chart shows.</a:t>
             </a:r>
@@ -2779,8 +2817,8 @@
         </p:nvSpPr>
         <p:spPr>
           <a:xfrm>
-            <a:off x="7315200" y="2560320"/>
-            <a:ext cx="1600200" cy="566928"/>
+            <a:off x="7315200" y="2514600"/>
+            <a:ext cx="1691640" cy="457200"/>
           </a:xfrm>
           <a:prstGeom prst="rect">
             <a:avLst/>
@@ -2796,7 +2834,7 @@
               <a:buNone/>
             </a:pPr>
             <a:r>
-              <a:rPr lang="en-US" sz="2600" b="1" dirty="0">
+              <a:rPr lang="en-US" sz="2200" b="1" dirty="0">
                 <a:solidFill>
                   <a:srgbClr val="E8702A"/>
                 </a:solidFill>
@@ -2804,9 +2842,9 @@
                 <a:ea typeface="Arial" pitchFamily="34" charset="-122"/>
                 <a:cs typeface="Arial" pitchFamily="34" charset="-120"/>
               </a:rPr>
-              <a:t>88 / 90</a:t>
-            </a:r>
-            <a:endParaRPr lang="en-US" sz="2600" dirty="0"/>
+              <a:t>90 / 90</a:t>
+            </a:r>
+            <a:endParaRPr lang="en-US" sz="2200" dirty="0"/>
           </a:p>
         </p:txBody>
       </p:sp>
@@ -2818,8 +2856,8 @@
         </p:nvSpPr>
         <p:spPr>
           <a:xfrm>
-            <a:off x="8961120" y="2560320"/>
-            <a:ext cx="2651760" cy="566928"/>
+            <a:off x="9052560" y="2514600"/>
+            <a:ext cx="2606040" cy="457200"/>
           </a:xfrm>
           <a:prstGeom prst="rect">
             <a:avLst/>
@@ -2835,7 +2873,7 @@
               <a:buNone/>
             </a:pPr>
             <a:r>
-              <a:rPr lang="en-US" sz="1150" dirty="0">
+              <a:rPr lang="en-US" sz="1050" dirty="0">
                 <a:solidFill>
                   <a:srgbClr val="2B2F36"/>
                 </a:solidFill>
@@ -2843,9 +2881,9 @@
                 <a:ea typeface="Calibri" pitchFamily="34" charset="-122"/>
                 <a:cs typeface="Calibri" pitchFamily="34" charset="-120"/>
               </a:rPr>
-              <a:t>Netlib LPs solved to the known optimum by at least one NIRNAY engine</a:t>
-            </a:r>
-            <a:endParaRPr lang="en-US" sz="1150" dirty="0"/>
+              <a:t>Netlib LPs solved to the known optimum by our dual simplex</a:t>
+            </a:r>
+            <a:endParaRPr lang="en-US" sz="1050" dirty="0"/>
           </a:p>
         </p:txBody>
       </p:sp>
@@ -2857,8 +2895,8 @@
         </p:nvSpPr>
         <p:spPr>
           <a:xfrm>
-            <a:off x="7315200" y="3236976"/>
-            <a:ext cx="1600200" cy="566928"/>
+            <a:off x="7315200" y="3026664"/>
+            <a:ext cx="1691640" cy="457200"/>
           </a:xfrm>
           <a:prstGeom prst="rect">
             <a:avLst/>
@@ -2874,7 +2912,7 @@
               <a:buNone/>
             </a:pPr>
             <a:r>
-              <a:rPr lang="en-US" sz="2600" b="1" dirty="0">
+              <a:rPr lang="en-US" sz="2200" b="1" dirty="0">
                 <a:solidFill>
                   <a:srgbClr val="E8702A"/>
                 </a:solidFill>
@@ -2882,9 +2920,9 @@
                 <a:ea typeface="Arial" pitchFamily="34" charset="-122"/>
                 <a:cs typeface="Arial" pitchFamily="34" charset="-120"/>
               </a:rPr>
-              <a:t>86 / 90</a:t>
-            </a:r>
-            <a:endParaRPr lang="en-US" sz="2600" dirty="0"/>
+              <a:t>33 / 64</a:t>
+            </a:r>
+            <a:endParaRPr lang="en-US" sz="2200" dirty="0"/>
           </a:p>
         </p:txBody>
       </p:sp>
@@ -2896,8 +2934,8 @@
         </p:nvSpPr>
         <p:spPr>
           <a:xfrm>
-            <a:off x="8961120" y="3236976"/>
-            <a:ext cx="2651760" cy="566928"/>
+            <a:off x="9052560" y="3026664"/>
+            <a:ext cx="2606040" cy="457200"/>
           </a:xfrm>
           <a:prstGeom prst="rect">
             <a:avLst/>
@@ -2913,7 +2951,7 @@
               <a:buNone/>
             </a:pPr>
             <a:r>
-              <a:rPr lang="en-US" sz="1150" dirty="0">
+              <a:rPr lang="en-US" sz="1050" dirty="0">
                 <a:solidFill>
                   <a:srgbClr val="2B2F36"/>
                 </a:solidFill>
@@ -2921,9 +2959,9 @@
                 <a:ea typeface="Calibri" pitchFamily="34" charset="-122"/>
                 <a:cs typeface="Calibri" pitchFamily="34" charset="-120"/>
               </a:rPr>
-              <a:t>by our interior-point method alone (Mehrotra predictor-corrector)</a:t>
-            </a:r>
-            <a:endParaRPr lang="en-US" sz="1150" dirty="0"/>
+              <a:t>MIPLIB 3 problems proven optimal in 60 s by our branch-and-bound</a:t>
+            </a:r>
+            <a:endParaRPr lang="en-US" sz="1050" dirty="0"/>
           </a:p>
         </p:txBody>
       </p:sp>
@@ -2935,8 +2973,8 @@
         </p:nvSpPr>
         <p:spPr>
           <a:xfrm>
-            <a:off x="7315200" y="3913632"/>
-            <a:ext cx="1600200" cy="566928"/>
+            <a:off x="7315200" y="3538728"/>
+            <a:ext cx="1691640" cy="457200"/>
           </a:xfrm>
           <a:prstGeom prst="rect">
             <a:avLst/>
@@ -2952,17 +2990,17 @@
               <a:buNone/>
             </a:pPr>
             <a:r>
-              <a:rPr lang="en-US" sz="2600" b="1" dirty="0">
-                <a:solidFill>
-                  <a:srgbClr val="1E8C45"/>
+              <a:rPr lang="en-US" sz="2200" b="1" dirty="0">
+                <a:solidFill>
+                  <a:srgbClr val="E8702A"/>
                 </a:solidFill>
                 <a:latin typeface="Arial" pitchFamily="34" charset="0"/>
                 <a:ea typeface="Arial" pitchFamily="34" charset="-122"/>
                 <a:cs typeface="Arial" pitchFamily="34" charset="-120"/>
               </a:rPr>
-              <a:t>0</a:t>
-            </a:r>
-            <a:endParaRPr lang="en-US" sz="2600" dirty="0"/>
+              <a:t>121 / 138</a:t>
+            </a:r>
+            <a:endParaRPr lang="en-US" sz="2200" dirty="0"/>
           </a:p>
         </p:txBody>
       </p:sp>
@@ -2974,8 +3012,8 @@
         </p:nvSpPr>
         <p:spPr>
           <a:xfrm>
-            <a:off x="8961120" y="3913632"/>
-            <a:ext cx="2651760" cy="566928"/>
+            <a:off x="9052560" y="3538728"/>
+            <a:ext cx="2606040" cy="457200"/>
           </a:xfrm>
           <a:prstGeom prst="rect">
             <a:avLst/>
@@ -2991,7 +3029,7 @@
               <a:buNone/>
             </a:pPr>
             <a:r>
-              <a:rPr lang="en-US" sz="1150" dirty="0">
+              <a:rPr lang="en-US" sz="1050" dirty="0">
                 <a:solidFill>
                   <a:srgbClr val="2B2F36"/>
                 </a:solidFill>
@@ -2999,9 +3037,9 @@
                 <a:ea typeface="Calibri" pitchFamily="34" charset="-122"/>
                 <a:cs typeface="Calibri" pitchFamily="34" charset="-120"/>
               </a:rPr>
-              <a:t>optimisation libraries inside: sparse LU, Cholesky and orderings are ours</a:t>
-            </a:r>
-            <a:endParaRPr lang="en-US" sz="1150" dirty="0"/>
+              <a:t>Maros–Mészáros convex QPs solved by our QP interior point</a:t>
+            </a:r>
+            <a:endParaRPr lang="en-US" sz="1050" dirty="0"/>
           </a:p>
         </p:txBody>
       </p:sp>
@@ -3013,8 +3051,8 @@
         </p:nvSpPr>
         <p:spPr>
           <a:xfrm>
-            <a:off x="457200" y="4754880"/>
-            <a:ext cx="7315200" cy="274320"/>
+            <a:off x="7315200" y="4050792"/>
+            <a:ext cx="1691640" cy="457200"/>
           </a:xfrm>
           <a:prstGeom prst="rect">
             <a:avLst/>
@@ -3030,14 +3068,92 @@
               <a:buNone/>
             </a:pPr>
             <a:r>
-              <a:rPr lang="en-US" sz="1200" b="1" spc="100" kern="0" dirty="0">
-                <a:solidFill>
-                  <a:srgbClr val="1F2A44"/>
+              <a:rPr lang="en-US" sz="2200" b="1" dirty="0">
+                <a:solidFill>
+                  <a:srgbClr val="1E8C45"/>
                 </a:solidFill>
                 <a:latin typeface="Arial" pitchFamily="34" charset="0"/>
                 <a:ea typeface="Arial" pitchFamily="34" charset="-122"/>
                 <a:cs typeface="Arial" pitchFamily="34" charset="-120"/>
               </a:rPr>
+              <a:t>0</a:t>
+            </a:r>
+            <a:endParaRPr lang="en-US" sz="2200" dirty="0"/>
+          </a:p>
+        </p:txBody>
+      </p:sp>
+      <p:sp>
+        <p:nvSpPr>
+          <p:cNvPr id="18" name="Text 15"/>
+          <p:cNvSpPr txBox="1"/>
+          <p:nvPr/>
+        </p:nvSpPr>
+        <p:spPr>
+          <a:xfrm>
+            <a:off x="9052560" y="4050792"/>
+            <a:ext cx="2606040" cy="457200"/>
+          </a:xfrm>
+          <a:prstGeom prst="rect">
+            <a:avLst/>
+          </a:prstGeom>
+          <a:noFill/>
+          <a:ln/>
+        </p:spPr>
+        <p:txBody>
+          <a:bodyPr wrap="square" lIns="0" tIns="0" rIns="0" bIns="0" rtlCol="0" anchor="ctr"/>
+          <a:lstStyle/>
+          <a:p>
+            <a:pPr indent="0" marL="0">
+              <a:buNone/>
+            </a:pPr>
+            <a:r>
+              <a:rPr lang="en-US" sz="1050" dirty="0">
+                <a:solidFill>
+                  <a:srgbClr val="2B2F36"/>
+                </a:solidFill>
+                <a:latin typeface="Calibri" pitchFamily="34" charset="0"/>
+                <a:ea typeface="Calibri" pitchFamily="34" charset="-122"/>
+                <a:cs typeface="Calibri" pitchFamily="34" charset="-120"/>
+              </a:rPr>
+              <a:t>optimisation libraries inside: LU, Cholesky, LDLᵀ and orderings are ours</a:t>
+            </a:r>
+            <a:endParaRPr lang="en-US" sz="1050" dirty="0"/>
+          </a:p>
+        </p:txBody>
+      </p:sp>
+      <p:sp>
+        <p:nvSpPr>
+          <p:cNvPr id="19" name="Text 16"/>
+          <p:cNvSpPr txBox="1"/>
+          <p:nvPr/>
+        </p:nvSpPr>
+        <p:spPr>
+          <a:xfrm>
+            <a:off x="457200" y="4754880"/>
+            <a:ext cx="7315200" cy="274320"/>
+          </a:xfrm>
+          <a:prstGeom prst="rect">
+            <a:avLst/>
+          </a:prstGeom>
+          <a:noFill/>
+          <a:ln/>
+        </p:spPr>
+        <p:txBody>
+          <a:bodyPr wrap="square" lIns="0" tIns="0" rIns="0" bIns="0" rtlCol="0" anchor="ctr"/>
+          <a:lstStyle/>
+          <a:p>
+            <a:pPr indent="0" marL="0">
+              <a:buNone/>
+            </a:pPr>
+            <a:r>
+              <a:rPr lang="en-US" sz="1200" b="1" spc="100" kern="0" dirty="0">
+                <a:solidFill>
+                  <a:srgbClr val="1F2A44"/>
+                </a:solidFill>
+                <a:latin typeface="Arial" pitchFamily="34" charset="0"/>
+                <a:ea typeface="Arial" pitchFamily="34" charset="-122"/>
+                <a:cs typeface="Arial" pitchFamily="34" charset="-120"/>
+              </a:rPr>
               <a:t>INNOVATION AND UNIQUENESS</a:t>
             </a:r>
             <a:endParaRPr lang="en-US" sz="1200" dirty="0"/>
@@ -3046,7 +3162,7 @@
       </p:sp>
       <p:sp>
         <p:nvSpPr>
-          <p:cNvPr id="18" name="Shape 15"/>
+          <p:cNvPr id="20" name="Shape 17"/>
           <p:cNvSpPr/>
           <p:nvPr/>
         </p:nvSpPr>
@@ -3071,7 +3187,7 @@
       </p:sp>
       <p:sp>
         <p:nvSpPr>
-          <p:cNvPr id="19" name="Text 16"/>
+          <p:cNvPr id="21" name="Text 18"/>
           <p:cNvSpPr txBox="1"/>
           <p:nvPr/>
         </p:nvSpPr>
@@ -3110,7 +3226,7 @@
       </p:sp>
       <p:sp>
         <p:nvSpPr>
-          <p:cNvPr id="20" name="Text 17"/>
+          <p:cNvPr id="22" name="Text 19"/>
           <p:cNvSpPr txBox="1"/>
           <p:nvPr/>
         </p:nvSpPr>
@@ -3149,7 +3265,7 @@
       </p:sp>
       <p:sp>
         <p:nvSpPr>
-          <p:cNvPr id="21" name="Text 18"/>
+          <p:cNvPr id="23" name="Text 20"/>
           <p:cNvSpPr txBox="1"/>
           <p:nvPr/>
         </p:nvSpPr>
@@ -3188,7 +3304,7 @@
       </p:sp>
       <p:sp>
         <p:nvSpPr>
-          <p:cNvPr id="22" name="Shape 19"/>
+          <p:cNvPr id="24" name="Shape 21"/>
           <p:cNvSpPr/>
           <p:nvPr/>
         </p:nvSpPr>
@@ -3213,7 +3329,7 @@
       </p:sp>
       <p:sp>
         <p:nvSpPr>
-          <p:cNvPr id="23" name="Text 20"/>
+          <p:cNvPr id="25" name="Text 22"/>
           <p:cNvSpPr txBox="1"/>
           <p:nvPr/>
         </p:nvSpPr>
@@ -3252,7 +3368,7 @@
       </p:sp>
       <p:sp>
         <p:nvSpPr>
-          <p:cNvPr id="24" name="Text 21"/>
+          <p:cNvPr id="26" name="Text 23"/>
           <p:cNvSpPr txBox="1"/>
           <p:nvPr/>
         </p:nvSpPr>
@@ -3291,7 +3407,7 @@
       </p:sp>
       <p:sp>
         <p:nvSpPr>
-          <p:cNvPr id="25" name="Text 22"/>
+          <p:cNvPr id="27" name="Text 24"/>
           <p:cNvSpPr txBox="1"/>
           <p:nvPr/>
         </p:nvSpPr>
@@ -3330,7 +3446,7 @@
       </p:sp>
       <p:sp>
         <p:nvSpPr>
-          <p:cNvPr id="26" name="Shape 23"/>
+          <p:cNvPr id="28" name="Shape 25"/>
           <p:cNvSpPr/>
           <p:nvPr/>
         </p:nvSpPr>
@@ -3355,7 +3471,7 @@
       </p:sp>
       <p:sp>
         <p:nvSpPr>
-          <p:cNvPr id="27" name="Text 24"/>
+          <p:cNvPr id="29" name="Text 26"/>
           <p:cNvSpPr txBox="1"/>
           <p:nvPr/>
         </p:nvSpPr>
@@ -3394,7 +3510,7 @@
       </p:sp>
       <p:sp>
         <p:nvSpPr>
-          <p:cNvPr id="28" name="Text 25"/>
+          <p:cNvPr id="30" name="Text 27"/>
           <p:cNvSpPr txBox="1"/>
           <p:nvPr/>
         </p:nvSpPr>
@@ -3433,7 +3549,7 @@
       </p:sp>
       <p:sp>
         <p:nvSpPr>
-          <p:cNvPr id="29" name="Text 26"/>
+          <p:cNvPr id="31" name="Text 28"/>
           <p:cNvSpPr txBox="1"/>
           <p:nvPr/>
         </p:nvSpPr>
@@ -3472,7 +3588,7 @@
       </p:sp>
       <p:sp>
         <p:nvSpPr>
-          <p:cNvPr id="30" name="Shape 27"/>
+          <p:cNvPr id="32" name="Shape 29"/>
           <p:cNvSpPr/>
           <p:nvPr/>
         </p:nvSpPr>
@@ -3497,7 +3613,7 @@
       </p:sp>
       <p:sp>
         <p:nvSpPr>
-          <p:cNvPr id="31" name="Text 28"/>
+          <p:cNvPr id="33" name="Text 30"/>
           <p:cNvSpPr txBox="1"/>
           <p:nvPr/>
         </p:nvSpPr>
@@ -3536,7 +3652,7 @@
       </p:sp>
       <p:sp>
         <p:nvSpPr>
-          <p:cNvPr id="32" name="Text 29"/>
+          <p:cNvPr id="34" name="Text 31"/>
           <p:cNvSpPr txBox="1"/>
           <p:nvPr/>
         </p:nvSpPr>
@@ -3575,7 +3691,7 @@
       </p:sp>
       <p:sp>
         <p:nvSpPr>
-          <p:cNvPr id="33" name="Text 30"/>
+          <p:cNvPr id="35" name="Text 32"/>
           <p:cNvSpPr txBox="1"/>
           <p:nvPr/>
         </p:nvSpPr>
@@ -3606,7 +3722,7 @@
                 <a:ea typeface="Calibri" pitchFamily="34" charset="-122"/>
                 <a:cs typeface="Calibri" pitchFamily="34" charset="-120"/>
               </a:rPr>
-              <a:t>Netlib, MIPLIB and Maros–Mészáros, plus public refinery-blending, unit-commitment and supply-chain models, each checked against HiGHS.</a:t>
+              <a:t>Netlib, MIPLIB and Maros–Mészáros, plus public refinery-blending, unit-commitment and supply-chain models, each checked against a reference solver.</a:t>
             </a:r>
             <a:endParaRPr lang="en-US" sz="1000" dirty="0"/>
           </a:p>
@@ -3897,7 +4013,7 @@
         <p:spPr>
           <a:xfrm>
             <a:off x="2057400" y="1463040"/>
-            <a:ext cx="5486400" cy="566928"/>
+            <a:ext cx="4526280" cy="566928"/>
           </a:xfrm>
           <a:prstGeom prst="rect">
             <a:avLst/>
@@ -3930,6 +4046,72 @@
       <p:sp>
         <p:nvSpPr>
           <p:cNvPr id="10" name="Shape 7"/>
+          <p:cNvSpPr/>
+          <p:nvPr/>
+        </p:nvSpPr>
+        <p:spPr>
+          <a:xfrm>
+            <a:off x="6675120" y="1627632"/>
+            <a:ext cx="868680" cy="237744"/>
+          </a:xfrm>
+          <a:prstGeom prst="roundRect">
+            <a:avLst>
+              <a:gd name="adj" fmla="val 19231"/>
+            </a:avLst>
+          </a:prstGeom>
+          <a:solidFill>
+            <a:srgbClr val="FFFFFF"/>
+          </a:solidFill>
+          <a:ln w="12700">
+            <a:solidFill>
+              <a:srgbClr val="1E8C45"/>
+            </a:solidFill>
+            <a:prstDash val="solid"/>
+          </a:ln>
+        </p:spPr>
+      </p:sp>
+      <p:sp>
+        <p:nvSpPr>
+          <p:cNvPr id="11" name="Text 8"/>
+          <p:cNvSpPr txBox="1"/>
+          <p:nvPr/>
+        </p:nvSpPr>
+        <p:spPr>
+          <a:xfrm>
+            <a:off x="6675120" y="1627632"/>
+            <a:ext cx="868680" cy="237744"/>
+          </a:xfrm>
+          <a:prstGeom prst="rect">
+            <a:avLst/>
+          </a:prstGeom>
+          <a:noFill/>
+          <a:ln/>
+        </p:spPr>
+        <p:txBody>
+          <a:bodyPr wrap="square" lIns="0" tIns="0" rIns="0" bIns="0" rtlCol="0" anchor="ctr"/>
+          <a:lstStyle/>
+          <a:p>
+            <a:pPr algn="ctr" indent="0" marL="0">
+              <a:buNone/>
+            </a:pPr>
+            <a:r>
+              <a:rPr lang="en-US" sz="800" b="1" dirty="0">
+                <a:solidFill>
+                  <a:srgbClr val="1E8C45"/>
+                </a:solidFill>
+                <a:latin typeface="Arial" pitchFamily="34" charset="0"/>
+                <a:ea typeface="Arial" pitchFamily="34" charset="-122"/>
+                <a:cs typeface="Arial" pitchFamily="34" charset="-120"/>
+              </a:rPr>
+              <a:t>BUILT</a:t>
+            </a:r>
+            <a:endParaRPr lang="en-US" sz="800" dirty="0"/>
+          </a:p>
+        </p:txBody>
+      </p:sp>
+      <p:sp>
+        <p:nvSpPr>
+          <p:cNvPr id="12" name="Shape 9"/>
           <p:cNvSpPr/>
           <p:nvPr/>
         </p:nvSpPr>
@@ -3954,7 +4136,7 @@
       </p:sp>
       <p:sp>
         <p:nvSpPr>
-          <p:cNvPr id="11" name="Text 8"/>
+          <p:cNvPr id="13" name="Text 10"/>
           <p:cNvSpPr txBox="1"/>
           <p:nvPr/>
         </p:nvSpPr>
@@ -3993,14 +4175,14 @@
       </p:sp>
       <p:sp>
         <p:nvSpPr>
-          <p:cNvPr id="12" name="Text 9"/>
+          <p:cNvPr id="14" name="Text 11"/>
           <p:cNvSpPr txBox="1"/>
           <p:nvPr/>
         </p:nvSpPr>
         <p:spPr>
           <a:xfrm>
             <a:off x="2057400" y="2121408"/>
-            <a:ext cx="5486400" cy="566928"/>
+            <a:ext cx="4526280" cy="566928"/>
           </a:xfrm>
           <a:prstGeom prst="rect">
             <a:avLst/>
@@ -4024,7 +4206,7 @@
                 <a:ea typeface="Calibri" pitchFamily="34" charset="-122"/>
                 <a:cs typeface="Calibri" pitchFamily="34" charset="-120"/>
               </a:rPr>
-              <a:t>Fixed columns, free and singleton rows, bound tightening · geometric scaling in powers of two</a:t>
+              <a:t>Scaling in powers of two · singleton, empty and redundant rows · fixed and free-singleton columns · exact dual postsolve</a:t>
             </a:r>
             <a:endParaRPr lang="en-US" sz="1150" dirty="0"/>
           </a:p>
@@ -4032,7 +4214,73 @@
       </p:sp>
       <p:sp>
         <p:nvSpPr>
-          <p:cNvPr id="13" name="Shape 10"/>
+          <p:cNvPr id="15" name="Shape 12"/>
+          <p:cNvSpPr/>
+          <p:nvPr/>
+        </p:nvSpPr>
+        <p:spPr>
+          <a:xfrm>
+            <a:off x="6675120" y="2286000"/>
+            <a:ext cx="868680" cy="237744"/>
+          </a:xfrm>
+          <a:prstGeom prst="roundRect">
+            <a:avLst>
+              <a:gd name="adj" fmla="val 19231"/>
+            </a:avLst>
+          </a:prstGeom>
+          <a:solidFill>
+            <a:srgbClr val="FFFFFF"/>
+          </a:solidFill>
+          <a:ln w="12700">
+            <a:solidFill>
+              <a:srgbClr val="1E8C45"/>
+            </a:solidFill>
+            <a:prstDash val="solid"/>
+          </a:ln>
+        </p:spPr>
+      </p:sp>
+      <p:sp>
+        <p:nvSpPr>
+          <p:cNvPr id="16" name="Text 13"/>
+          <p:cNvSpPr txBox="1"/>
+          <p:nvPr/>
+        </p:nvSpPr>
+        <p:spPr>
+          <a:xfrm>
+            <a:off x="6675120" y="2286000"/>
+            <a:ext cx="868680" cy="237744"/>
+          </a:xfrm>
+          <a:prstGeom prst="rect">
+            <a:avLst/>
+          </a:prstGeom>
+          <a:noFill/>
+          <a:ln/>
+        </p:spPr>
+        <p:txBody>
+          <a:bodyPr wrap="square" lIns="0" tIns="0" rIns="0" bIns="0" rtlCol="0" anchor="ctr"/>
+          <a:lstStyle/>
+          <a:p>
+            <a:pPr algn="ctr" indent="0" marL="0">
+              <a:buNone/>
+            </a:pPr>
+            <a:r>
+              <a:rPr lang="en-US" sz="800" b="1" dirty="0">
+                <a:solidFill>
+                  <a:srgbClr val="1E8C45"/>
+                </a:solidFill>
+                <a:latin typeface="Arial" pitchFamily="34" charset="0"/>
+                <a:ea typeface="Arial" pitchFamily="34" charset="-122"/>
+                <a:cs typeface="Arial" pitchFamily="34" charset="-120"/>
+              </a:rPr>
+              <a:t>BUILT</a:t>
+            </a:r>
+            <a:endParaRPr lang="en-US" sz="800" dirty="0"/>
+          </a:p>
+        </p:txBody>
+      </p:sp>
+      <p:sp>
+        <p:nvSpPr>
+          <p:cNvPr id="17" name="Shape 14"/>
           <p:cNvSpPr/>
           <p:nvPr/>
         </p:nvSpPr>
@@ -4057,14 +4305,14 @@
       </p:sp>
       <p:sp>
         <p:nvSpPr>
-          <p:cNvPr id="14" name="Text 11"/>
+          <p:cNvPr id="18" name="Text 15"/>
           <p:cNvSpPr txBox="1"/>
           <p:nvPr/>
         </p:nvSpPr>
         <p:spPr>
           <a:xfrm>
             <a:off x="566928" y="2852928"/>
-            <a:ext cx="2097024" cy="320040"/>
+            <a:ext cx="1219200" cy="320040"/>
           </a:xfrm>
           <a:prstGeom prst="rect">
             <a:avLst/>
@@ -4096,7 +4344,73 @@
       </p:sp>
       <p:sp>
         <p:nvSpPr>
-          <p:cNvPr id="15" name="Text 12"/>
+          <p:cNvPr id="19" name="Shape 16"/>
+          <p:cNvSpPr/>
+          <p:nvPr/>
+        </p:nvSpPr>
+        <p:spPr>
+          <a:xfrm>
+            <a:off x="1813560" y="2889504"/>
+            <a:ext cx="868680" cy="237744"/>
+          </a:xfrm>
+          <a:prstGeom prst="roundRect">
+            <a:avLst>
+              <a:gd name="adj" fmla="val 19231"/>
+            </a:avLst>
+          </a:prstGeom>
+          <a:solidFill>
+            <a:srgbClr val="FFFFFF"/>
+          </a:solidFill>
+          <a:ln w="12700">
+            <a:solidFill>
+              <a:srgbClr val="1E8C45"/>
+            </a:solidFill>
+            <a:prstDash val="solid"/>
+          </a:ln>
+        </p:spPr>
+      </p:sp>
+      <p:sp>
+        <p:nvSpPr>
+          <p:cNvPr id="20" name="Text 17"/>
+          <p:cNvSpPr txBox="1"/>
+          <p:nvPr/>
+        </p:nvSpPr>
+        <p:spPr>
+          <a:xfrm>
+            <a:off x="1813560" y="2889504"/>
+            <a:ext cx="868680" cy="237744"/>
+          </a:xfrm>
+          <a:prstGeom prst="rect">
+            <a:avLst/>
+          </a:prstGeom>
+          <a:noFill/>
+          <a:ln/>
+        </p:spPr>
+        <p:txBody>
+          <a:bodyPr wrap="square" lIns="0" tIns="0" rIns="0" bIns="0" rtlCol="0" anchor="ctr"/>
+          <a:lstStyle/>
+          <a:p>
+            <a:pPr algn="ctr" indent="0" marL="0">
+              <a:buNone/>
+            </a:pPr>
+            <a:r>
+              <a:rPr lang="en-US" sz="800" b="1" dirty="0">
+                <a:solidFill>
+                  <a:srgbClr val="1E8C45"/>
+                </a:solidFill>
+                <a:latin typeface="Arial" pitchFamily="34" charset="0"/>
+                <a:ea typeface="Arial" pitchFamily="34" charset="-122"/>
+                <a:cs typeface="Arial" pitchFamily="34" charset="-120"/>
+              </a:rPr>
+              <a:t>BUILT</a:t>
+            </a:r>
+            <a:endParaRPr lang="en-US" sz="800" dirty="0"/>
+          </a:p>
+        </p:txBody>
+      </p:sp>
+      <p:sp>
+        <p:nvSpPr>
+          <p:cNvPr id="21" name="Text 18"/>
           <p:cNvSpPr txBox="1"/>
           <p:nvPr/>
         </p:nvSpPr>
@@ -4135,7 +4449,7 @@
       </p:sp>
       <p:sp>
         <p:nvSpPr>
-          <p:cNvPr id="16" name="Shape 13"/>
+          <p:cNvPr id="22" name="Shape 19"/>
           <p:cNvSpPr/>
           <p:nvPr/>
         </p:nvSpPr>
@@ -4160,14 +4474,14 @@
       </p:sp>
       <p:sp>
         <p:nvSpPr>
-          <p:cNvPr id="17" name="Text 14"/>
+          <p:cNvPr id="23" name="Text 20"/>
           <p:cNvSpPr txBox="1"/>
           <p:nvPr/>
         </p:nvSpPr>
         <p:spPr>
           <a:xfrm>
             <a:off x="3020568" y="2852928"/>
-            <a:ext cx="2097024" cy="320040"/>
+            <a:ext cx="1219200" cy="320040"/>
           </a:xfrm>
           <a:prstGeom prst="rect">
             <a:avLst/>
@@ -4199,7 +4513,73 @@
       </p:sp>
       <p:sp>
         <p:nvSpPr>
-          <p:cNvPr id="18" name="Text 15"/>
+          <p:cNvPr id="24" name="Shape 21"/>
+          <p:cNvSpPr/>
+          <p:nvPr/>
+        </p:nvSpPr>
+        <p:spPr>
+          <a:xfrm>
+            <a:off x="4267200" y="2889504"/>
+            <a:ext cx="868680" cy="237744"/>
+          </a:xfrm>
+          <a:prstGeom prst="roundRect">
+            <a:avLst>
+              <a:gd name="adj" fmla="val 19231"/>
+            </a:avLst>
+          </a:prstGeom>
+          <a:solidFill>
+            <a:srgbClr val="FFFFFF"/>
+          </a:solidFill>
+          <a:ln w="12700">
+            <a:solidFill>
+              <a:srgbClr val="1E8C45"/>
+            </a:solidFill>
+            <a:prstDash val="solid"/>
+          </a:ln>
+        </p:spPr>
+      </p:sp>
+      <p:sp>
+        <p:nvSpPr>
+          <p:cNvPr id="25" name="Text 22"/>
+          <p:cNvSpPr txBox="1"/>
+          <p:nvPr/>
+        </p:nvSpPr>
+        <p:spPr>
+          <a:xfrm>
+            <a:off x="4267200" y="2889504"/>
+            <a:ext cx="868680" cy="237744"/>
+          </a:xfrm>
+          <a:prstGeom prst="rect">
+            <a:avLst/>
+          </a:prstGeom>
+          <a:noFill/>
+          <a:ln/>
+        </p:spPr>
+        <p:txBody>
+          <a:bodyPr wrap="square" lIns="0" tIns="0" rIns="0" bIns="0" rtlCol="0" anchor="ctr"/>
+          <a:lstStyle/>
+          <a:p>
+            <a:pPr algn="ctr" indent="0" marL="0">
+              <a:buNone/>
+            </a:pPr>
+            <a:r>
+              <a:rPr lang="en-US" sz="800" b="1" dirty="0">
+                <a:solidFill>
+                  <a:srgbClr val="1E8C45"/>
+                </a:solidFill>
+                <a:latin typeface="Arial" pitchFamily="34" charset="0"/>
+                <a:ea typeface="Arial" pitchFamily="34" charset="-122"/>
+                <a:cs typeface="Arial" pitchFamily="34" charset="-120"/>
+              </a:rPr>
+              <a:t>BUILT</a:t>
+            </a:r>
+            <a:endParaRPr lang="en-US" sz="800" dirty="0"/>
+          </a:p>
+        </p:txBody>
+      </p:sp>
+      <p:sp>
+        <p:nvSpPr>
+          <p:cNvPr id="26" name="Text 23"/>
           <p:cNvSpPr txBox="1"/>
           <p:nvPr/>
         </p:nvSpPr>
@@ -4238,7 +4618,7 @@
       </p:sp>
       <p:sp>
         <p:nvSpPr>
-          <p:cNvPr id="19" name="Shape 16"/>
+          <p:cNvPr id="27" name="Shape 24"/>
           <p:cNvSpPr/>
           <p:nvPr/>
         </p:nvSpPr>
@@ -4263,14 +4643,14 @@
       </p:sp>
       <p:sp>
         <p:nvSpPr>
-          <p:cNvPr id="20" name="Text 17"/>
+          <p:cNvPr id="28" name="Text 25"/>
           <p:cNvSpPr txBox="1"/>
           <p:nvPr/>
         </p:nvSpPr>
         <p:spPr>
           <a:xfrm>
             <a:off x="5474208" y="2852928"/>
-            <a:ext cx="2097024" cy="320040"/>
+            <a:ext cx="1219200" cy="320040"/>
           </a:xfrm>
           <a:prstGeom prst="rect">
             <a:avLst/>
@@ -4302,7 +4682,73 @@
       </p:sp>
       <p:sp>
         <p:nvSpPr>
-          <p:cNvPr id="21" name="Text 18"/>
+          <p:cNvPr id="29" name="Shape 26"/>
+          <p:cNvSpPr/>
+          <p:nvPr/>
+        </p:nvSpPr>
+        <p:spPr>
+          <a:xfrm>
+            <a:off x="6720840" y="2889504"/>
+            <a:ext cx="868680" cy="237744"/>
+          </a:xfrm>
+          <a:prstGeom prst="roundRect">
+            <a:avLst>
+              <a:gd name="adj" fmla="val 19231"/>
+            </a:avLst>
+          </a:prstGeom>
+          <a:solidFill>
+            <a:srgbClr val="FFFFFF"/>
+          </a:solidFill>
+          <a:ln w="12700">
+            <a:solidFill>
+              <a:srgbClr val="1E8C45"/>
+            </a:solidFill>
+            <a:prstDash val="solid"/>
+          </a:ln>
+        </p:spPr>
+      </p:sp>
+      <p:sp>
+        <p:nvSpPr>
+          <p:cNvPr id="30" name="Text 27"/>
+          <p:cNvSpPr txBox="1"/>
+          <p:nvPr/>
+        </p:nvSpPr>
+        <p:spPr>
+          <a:xfrm>
+            <a:off x="6720840" y="2889504"/>
+            <a:ext cx="868680" cy="237744"/>
+          </a:xfrm>
+          <a:prstGeom prst="rect">
+            <a:avLst/>
+          </a:prstGeom>
+          <a:noFill/>
+          <a:ln/>
+        </p:spPr>
+        <p:txBody>
+          <a:bodyPr wrap="square" lIns="0" tIns="0" rIns="0" bIns="0" rtlCol="0" anchor="ctr"/>
+          <a:lstStyle/>
+          <a:p>
+            <a:pPr algn="ctr" indent="0" marL="0">
+              <a:buNone/>
+            </a:pPr>
+            <a:r>
+              <a:rPr lang="en-US" sz="800" b="1" dirty="0">
+                <a:solidFill>
+                  <a:srgbClr val="1E8C45"/>
+                </a:solidFill>
+                <a:latin typeface="Arial" pitchFamily="34" charset="0"/>
+                <a:ea typeface="Arial" pitchFamily="34" charset="-122"/>
+                <a:cs typeface="Arial" pitchFamily="34" charset="-120"/>
+              </a:rPr>
+              <a:t>BUILT</a:t>
+            </a:r>
+            <a:endParaRPr lang="en-US" sz="800" dirty="0"/>
+          </a:p>
+        </p:txBody>
+      </p:sp>
+      <p:sp>
+        <p:nvSpPr>
+          <p:cNvPr id="31" name="Text 28"/>
           <p:cNvSpPr txBox="1"/>
           <p:nvPr/>
         </p:nvSpPr>
@@ -4341,7 +4787,7 @@
       </p:sp>
       <p:sp>
         <p:nvSpPr>
-          <p:cNvPr id="22" name="Shape 19"/>
+          <p:cNvPr id="32" name="Shape 29"/>
           <p:cNvSpPr/>
           <p:nvPr/>
         </p:nvSpPr>
@@ -4366,7 +4812,7 @@
       </p:sp>
       <p:sp>
         <p:nvSpPr>
-          <p:cNvPr id="23" name="Text 20"/>
+          <p:cNvPr id="33" name="Text 30"/>
           <p:cNvSpPr txBox="1"/>
           <p:nvPr/>
         </p:nvSpPr>
@@ -4405,14 +4851,14 @@
       </p:sp>
       <p:sp>
         <p:nvSpPr>
-          <p:cNvPr id="24" name="Text 21"/>
+          <p:cNvPr id="34" name="Text 31"/>
           <p:cNvSpPr txBox="1"/>
           <p:nvPr/>
         </p:nvSpPr>
         <p:spPr>
           <a:xfrm>
             <a:off x="2057400" y="4105656"/>
-            <a:ext cx="5486400" cy="566928"/>
+            <a:ext cx="4526280" cy="566928"/>
           </a:xfrm>
           <a:prstGeom prst="rect">
             <a:avLst/>
@@ -4436,7 +4882,7 @@
                 <a:ea typeface="Calibri" pitchFamily="34" charset="-122"/>
                 <a:cs typeface="Calibri" pitchFamily="34" charset="-120"/>
               </a:rPr>
-              <a:t>Branch-and-bound on warm-started dual simplex · reliability branching · domain propagation · Gomory cuts · diving and rounding heuristics</a:t>
+              <a:t>Branch-and-bound on warm-started dual simplex · reliability branching · propagation · Gomory cuts · diving</a:t>
             </a:r>
             <a:endParaRPr lang="en-US" sz="1150" dirty="0"/>
           </a:p>
@@ -4444,7 +4890,73 @@
       </p:sp>
       <p:sp>
         <p:nvSpPr>
-          <p:cNvPr id="25" name="Shape 22"/>
+          <p:cNvPr id="35" name="Shape 32"/>
+          <p:cNvSpPr/>
+          <p:nvPr/>
+        </p:nvSpPr>
+        <p:spPr>
+          <a:xfrm>
+            <a:off x="6675120" y="4270248"/>
+            <a:ext cx="868680" cy="237744"/>
+          </a:xfrm>
+          <a:prstGeom prst="roundRect">
+            <a:avLst>
+              <a:gd name="adj" fmla="val 19231"/>
+            </a:avLst>
+          </a:prstGeom>
+          <a:solidFill>
+            <a:srgbClr val="FFFFFF"/>
+          </a:solidFill>
+          <a:ln w="12700">
+            <a:solidFill>
+              <a:srgbClr val="1E8C45"/>
+            </a:solidFill>
+            <a:prstDash val="solid"/>
+          </a:ln>
+        </p:spPr>
+      </p:sp>
+      <p:sp>
+        <p:nvSpPr>
+          <p:cNvPr id="36" name="Text 33"/>
+          <p:cNvSpPr txBox="1"/>
+          <p:nvPr/>
+        </p:nvSpPr>
+        <p:spPr>
+          <a:xfrm>
+            <a:off x="6675120" y="4270248"/>
+            <a:ext cx="868680" cy="237744"/>
+          </a:xfrm>
+          <a:prstGeom prst="rect">
+            <a:avLst/>
+          </a:prstGeom>
+          <a:noFill/>
+          <a:ln/>
+        </p:spPr>
+        <p:txBody>
+          <a:bodyPr wrap="square" lIns="0" tIns="0" rIns="0" bIns="0" rtlCol="0" anchor="ctr"/>
+          <a:lstStyle/>
+          <a:p>
+            <a:pPr algn="ctr" indent="0" marL="0">
+              <a:buNone/>
+            </a:pPr>
+            <a:r>
+              <a:rPr lang="en-US" sz="800" b="1" dirty="0">
+                <a:solidFill>
+                  <a:srgbClr val="1E8C45"/>
+                </a:solidFill>
+                <a:latin typeface="Arial" pitchFamily="34" charset="0"/>
+                <a:ea typeface="Arial" pitchFamily="34" charset="-122"/>
+                <a:cs typeface="Arial" pitchFamily="34" charset="-120"/>
+              </a:rPr>
+              <a:t>BUILT</a:t>
+            </a:r>
+            <a:endParaRPr lang="en-US" sz="800" dirty="0"/>
+          </a:p>
+        </p:txBody>
+      </p:sp>
+      <p:sp>
+        <p:nvSpPr>
+          <p:cNvPr id="37" name="Shape 34"/>
           <p:cNvSpPr/>
           <p:nvPr/>
         </p:nvSpPr>
@@ -4469,7 +4981,7 @@
       </p:sp>
       <p:sp>
         <p:nvSpPr>
-          <p:cNvPr id="26" name="Text 23"/>
+          <p:cNvPr id="38" name="Text 35"/>
           <p:cNvSpPr txBox="1"/>
           <p:nvPr/>
         </p:nvSpPr>
@@ -4508,14 +5020,14 @@
       </p:sp>
       <p:sp>
         <p:nvSpPr>
-          <p:cNvPr id="27" name="Text 24"/>
+          <p:cNvPr id="39" name="Text 36"/>
           <p:cNvSpPr txBox="1"/>
           <p:nvPr/>
         </p:nvSpPr>
         <p:spPr>
           <a:xfrm>
             <a:off x="2057400" y="4764024"/>
-            <a:ext cx="5486400" cy="566928"/>
+            <a:ext cx="4526280" cy="566928"/>
           </a:xfrm>
           <a:prstGeom prst="rect">
             <a:avLst/>
@@ -4539,7 +5051,7 @@
                 <a:ea typeface="Calibri" pitchFamily="34" charset="-122"/>
                 <a:cs typeface="Calibri" pitchFamily="34" charset="-120"/>
               </a:rPr>
-              <a:t>Convex quadratic programmes by interior point on the same Cholesky core; PDHG for large sparse QPs</a:t>
+              <a:t>Convex QP by interior point on the quasi-definite augmented system, own sparse LDLᵀ</a:t>
             </a:r>
             <a:endParaRPr lang="en-US" sz="1150" dirty="0"/>
           </a:p>
@@ -4547,7 +5059,73 @@
       </p:sp>
       <p:sp>
         <p:nvSpPr>
-          <p:cNvPr id="28" name="Shape 25"/>
+          <p:cNvPr id="40" name="Shape 37"/>
+          <p:cNvSpPr/>
+          <p:nvPr/>
+        </p:nvSpPr>
+        <p:spPr>
+          <a:xfrm>
+            <a:off x="6675120" y="4928616"/>
+            <a:ext cx="868680" cy="237744"/>
+          </a:xfrm>
+          <a:prstGeom prst="roundRect">
+            <a:avLst>
+              <a:gd name="adj" fmla="val 19231"/>
+            </a:avLst>
+          </a:prstGeom>
+          <a:solidFill>
+            <a:srgbClr val="FFFFFF"/>
+          </a:solidFill>
+          <a:ln w="12700">
+            <a:solidFill>
+              <a:srgbClr val="1E8C45"/>
+            </a:solidFill>
+            <a:prstDash val="solid"/>
+          </a:ln>
+        </p:spPr>
+      </p:sp>
+      <p:sp>
+        <p:nvSpPr>
+          <p:cNvPr id="41" name="Text 38"/>
+          <p:cNvSpPr txBox="1"/>
+          <p:nvPr/>
+        </p:nvSpPr>
+        <p:spPr>
+          <a:xfrm>
+            <a:off x="6675120" y="4928616"/>
+            <a:ext cx="868680" cy="237744"/>
+          </a:xfrm>
+          <a:prstGeom prst="rect">
+            <a:avLst/>
+          </a:prstGeom>
+          <a:noFill/>
+          <a:ln/>
+        </p:spPr>
+        <p:txBody>
+          <a:bodyPr wrap="square" lIns="0" tIns="0" rIns="0" bIns="0" rtlCol="0" anchor="ctr"/>
+          <a:lstStyle/>
+          <a:p>
+            <a:pPr algn="ctr" indent="0" marL="0">
+              <a:buNone/>
+            </a:pPr>
+            <a:r>
+              <a:rPr lang="en-US" sz="800" b="1" dirty="0">
+                <a:solidFill>
+                  <a:srgbClr val="1E8C45"/>
+                </a:solidFill>
+                <a:latin typeface="Arial" pitchFamily="34" charset="0"/>
+                <a:ea typeface="Arial" pitchFamily="34" charset="-122"/>
+                <a:cs typeface="Arial" pitchFamily="34" charset="-120"/>
+              </a:rPr>
+              <a:t>BUILT</a:t>
+            </a:r>
+            <a:endParaRPr lang="en-US" sz="800" dirty="0"/>
+          </a:p>
+        </p:txBody>
+      </p:sp>
+      <p:sp>
+        <p:nvSpPr>
+          <p:cNvPr id="42" name="Shape 39"/>
           <p:cNvSpPr/>
           <p:nvPr/>
         </p:nvSpPr>
@@ -4572,7 +5150,7 @@
       </p:sp>
       <p:sp>
         <p:nvSpPr>
-          <p:cNvPr id="29" name="Text 26"/>
+          <p:cNvPr id="43" name="Text 40"/>
           <p:cNvSpPr txBox="1"/>
           <p:nvPr/>
         </p:nvSpPr>
@@ -4611,14 +5189,14 @@
       </p:sp>
       <p:sp>
         <p:nvSpPr>
-          <p:cNvPr id="30" name="Text 27"/>
+          <p:cNvPr id="44" name="Text 41"/>
           <p:cNvSpPr txBox="1"/>
           <p:nvPr/>
         </p:nvSpPr>
         <p:spPr>
           <a:xfrm>
             <a:off x="2057400" y="5422392"/>
-            <a:ext cx="5486400" cy="566928"/>
+            <a:ext cx="4526280" cy="566928"/>
           </a:xfrm>
           <a:prstGeom prst="rect">
             <a:avLst/>
@@ -4642,7 +5220,7 @@
                 <a:ea typeface="Calibri" pitchFamily="34" charset="-122"/>
                 <a:cs typeface="Calibri" pitchFamily="34" charset="-120"/>
               </a:rPr>
-              <a:t>Numba-compiled native code on all CPU cores · CUDA kernels via CuPy on the GPU · no solver library anywhere</a:t>
+              <a:t>Numba-compiled native machine code · CUDA via CuPy on the GPU · no solver library anywhere</a:t>
             </a:r>
             <a:endParaRPr lang="en-US" sz="1150" dirty="0"/>
           </a:p>
@@ -4650,14 +5228,41 @@
       </p:sp>
       <p:sp>
         <p:nvSpPr>
-          <p:cNvPr id="31" name="Text 28"/>
-          <p:cNvSpPr txBox="1"/>
-          <p:nvPr/>
-        </p:nvSpPr>
-        <p:spPr>
-          <a:xfrm>
-            <a:off x="8046720" y="1463040"/>
-            <a:ext cx="3703320" cy="274320"/>
+          <p:cNvPr id="45" name="Shape 42"/>
+          <p:cNvSpPr/>
+          <p:nvPr/>
+        </p:nvSpPr>
+        <p:spPr>
+          <a:xfrm>
+            <a:off x="6675120" y="5586984"/>
+            <a:ext cx="868680" cy="237744"/>
+          </a:xfrm>
+          <a:prstGeom prst="roundRect">
+            <a:avLst>
+              <a:gd name="adj" fmla="val 19231"/>
+            </a:avLst>
+          </a:prstGeom>
+          <a:solidFill>
+            <a:srgbClr val="FFFFFF"/>
+          </a:solidFill>
+          <a:ln w="12700">
+            <a:solidFill>
+              <a:srgbClr val="1E8C45"/>
+            </a:solidFill>
+            <a:prstDash val="solid"/>
+          </a:ln>
+        </p:spPr>
+      </p:sp>
+      <p:sp>
+        <p:nvSpPr>
+          <p:cNvPr id="46" name="Text 43"/>
+          <p:cNvSpPr txBox="1"/>
+          <p:nvPr/>
+        </p:nvSpPr>
+        <p:spPr>
+          <a:xfrm>
+            <a:off x="6675120" y="5586984"/>
+            <a:ext cx="868680" cy="237744"/>
           </a:xfrm>
           <a:prstGeom prst="rect">
             <a:avLst/>
@@ -4669,18 +5274,57 @@
           <a:bodyPr wrap="square" lIns="0" tIns="0" rIns="0" bIns="0" rtlCol="0" anchor="ctr"/>
           <a:lstStyle/>
           <a:p>
-            <a:pPr indent="0" marL="0">
-              <a:buNone/>
-            </a:pPr>
-            <a:r>
-              <a:rPr lang="en-US" sz="1100" b="1" spc="100" kern="0" dirty="0">
-                <a:solidFill>
-                  <a:srgbClr val="5B6770"/>
+            <a:pPr algn="ctr" indent="0" marL="0">
+              <a:buNone/>
+            </a:pPr>
+            <a:r>
+              <a:rPr lang="en-US" sz="800" b="1" dirty="0">
+                <a:solidFill>
+                  <a:srgbClr val="1E8C45"/>
                 </a:solidFill>
                 <a:latin typeface="Arial" pitchFamily="34" charset="0"/>
                 <a:ea typeface="Arial" pitchFamily="34" charset="-122"/>
                 <a:cs typeface="Arial" pitchFamily="34" charset="-120"/>
               </a:rPr>
+              <a:t>BUILT</a:t>
+            </a:r>
+            <a:endParaRPr lang="en-US" sz="800" dirty="0"/>
+          </a:p>
+        </p:txBody>
+      </p:sp>
+      <p:sp>
+        <p:nvSpPr>
+          <p:cNvPr id="47" name="Text 44"/>
+          <p:cNvSpPr txBox="1"/>
+          <p:nvPr/>
+        </p:nvSpPr>
+        <p:spPr>
+          <a:xfrm>
+            <a:off x="8046720" y="1463040"/>
+            <a:ext cx="3703320" cy="274320"/>
+          </a:xfrm>
+          <a:prstGeom prst="rect">
+            <a:avLst/>
+          </a:prstGeom>
+          <a:noFill/>
+          <a:ln/>
+        </p:spPr>
+        <p:txBody>
+          <a:bodyPr wrap="square" lIns="0" tIns="0" rIns="0" bIns="0" rtlCol="0" anchor="ctr"/>
+          <a:lstStyle/>
+          <a:p>
+            <a:pPr indent="0" marL="0">
+              <a:buNone/>
+            </a:pPr>
+            <a:r>
+              <a:rPr lang="en-US" sz="1100" b="1" spc="100" kern="0" dirty="0">
+                <a:solidFill>
+                  <a:srgbClr val="5B6770"/>
+                </a:solidFill>
+                <a:latin typeface="Arial" pitchFamily="34" charset="0"/>
+                <a:ea typeface="Arial" pitchFamily="34" charset="-122"/>
+                <a:cs typeface="Arial" pitchFamily="34" charset="-120"/>
+              </a:rPr>
               <a:t>TECHNOLOGY</a:t>
             </a:r>
             <a:endParaRPr lang="en-US" sz="1100" dirty="0"/>
@@ -4689,7 +5333,7 @@
       </p:sp>
       <p:sp>
         <p:nvSpPr>
-          <p:cNvPr id="32" name="Text 29"/>
+          <p:cNvPr id="48" name="Text 45"/>
           <p:cNvSpPr txBox="1"/>
           <p:nvPr/>
         </p:nvSpPr>
@@ -4745,7 +5389,7 @@
                 <a:ea typeface="Calibri" pitchFamily="34" charset="-122"/>
                 <a:cs typeface="Calibri" pitchFamily="34" charset="-120"/>
               </a:rPr>
-              <a:t>Numba: kernels compiled to native, multi-threaded code</a:t>
+              <a:t>Numba: kernels compiled to native machine code</a:t>
             </a:r>
             <a:endParaRPr lang="en-US" sz="1200" dirty="0"/>
           </a:p>
@@ -4795,7 +5439,7 @@
       </p:sp>
       <p:sp>
         <p:nvSpPr>
-          <p:cNvPr id="33" name="Text 30"/>
+          <p:cNvPr id="49" name="Text 46"/>
           <p:cNvSpPr txBox="1"/>
           <p:nvPr/>
         </p:nvSpPr>
@@ -4834,7 +5478,7 @@
       </p:sp>
       <p:sp>
         <p:nvSpPr>
-          <p:cNvPr id="34" name="Text 31"/>
+          <p:cNvPr id="50" name="Text 47"/>
           <p:cNvSpPr txBox="1"/>
           <p:nvPr/>
         </p:nvSpPr>
@@ -4890,7 +5534,7 @@
                 <a:ea typeface="Calibri" pitchFamily="34" charset="-122"/>
                 <a:cs typeface="Calibri" pitchFamily="34" charset="-120"/>
               </a:rPr>
-              <a:t>Every instance re-solved by HiGHS as the reference; relative error and residuals logged</a:t>
+              <a:t>Every instance re-solved by a reference (HiGHS for LP and MILP, Clarabel for QP); errors and residuals logged</a:t>
             </a:r>
             <a:endParaRPr lang="en-US" sz="1200" dirty="0"/>
           </a:p>
@@ -5123,7 +5767,7 @@
                 <a:ea typeface="Calibri" pitchFamily="34" charset="-122"/>
                 <a:cs typeface="Calibri" pitchFamily="34" charset="-120"/>
               </a:rPr>
-              <a:t>Not a plan: the core already runs. Netlib LPs solved to the known optimum (relative error &lt; 1e-6 against HiGHS):</a:t>
+              <a:t>Not a plan: the core already runs. Share of each public benchmark set solved, NIRNAY against the reference solver on the same laptop:</a:t>
             </a:r>
             <a:endParaRPr lang="en-US" sz="1300" dirty="0"/>
           </a:p>
@@ -5178,7 +5822,7 @@
                 <a:ea typeface="Calibri" pitchFamily="34" charset="-122"/>
                 <a:cs typeface="Calibri" pitchFamily="34" charset="-120"/>
               </a:rPr>
-              <a:t>Simplex sweep covers 87 of 90 so far. Solutions agree with HiGHS to 1e-11 to 1e-15 where solved.</a:t>
+              <a:t>LP within 1e-6 of HiGHS (dual simplex 90, interior point 86); MILP proven optimal within 1e-4; QP within 1e-6 of Clarabel.</a:t>
             </a:r>
             <a:endParaRPr lang="en-US" sz="1050" dirty="0"/>
           </a:p>
@@ -5856,7 +6500,7 @@
                 <a:ea typeface="Calibri" pitchFamily="34" charset="-122"/>
                 <a:cs typeface="Calibri" pitchFamily="34" charset="-120"/>
               </a:rPr>
-              <a:t>Every number regenerates from one script against HiGHS on public benchmark files</a:t>
+              <a:t>Every number regenerates from one script against HiGHS and Clarabel on public benchmark files</a:t>
             </a:r>
             <a:endParaRPr lang="en-US" sz="1050" dirty="0"/>
           </a:p>
@@ -8218,7 +8862,7 @@
                 <a:ea typeface="Calibri" pitchFamily="34" charset="-122"/>
                 <a:cs typeface="Calibri" pitchFamily="34" charset="-120"/>
               </a:rPr>
-              <a:t>Maros &amp; Mészáros, Optim. Methods Softw. 11, 1999 — doi:10.1080/10556789908805768</a:t>
+              <a:t>Vanderbei, quasi-definite LDLᵀ, SIAM J. Optim. 5(1), 1995 — doi:10.1137/0805005; test set: Maros &amp; Mészáros, OMS 11, 1999</a:t>
             </a:r>
             <a:endParaRPr lang="en-US" sz="1100" dirty="0"/>
           </a:p>
@@ -8257,7 +8901,7 @@
                 <a:ea typeface="Calibri" pitchFamily="34" charset="-122"/>
                 <a:cs typeface="Calibri" pitchFamily="34" charset="-120"/>
               </a:rPr>
-              <a:t>Comparators used only in the benchmark harness, never inside the solver: HiGHS 1.15 (MIT), SCIP, OR-Tools. Benchmark data: Netlib via COIN-OR mirror, MIPLIB 3 / 2017 (miplib.zib.de).</a:t>
+              <a:t>Comparators used only in the benchmark harness, never inside the solver: HiGHS 1.15 (MIT), Clarabel 0.11 (Apache-2.0), SCIP, OR-Tools. Benchmark data: Netlib via COIN-OR mirror, MIPLIB 3 / 2017 (miplib.zib.de).</a:t>
             </a:r>
             <a:endParaRPr lang="en-US" sz="950" dirty="0"/>
           </a:p>

</xml_diff>

<commit_message>
Team ID 175338 on the deck, report title page and README
</commit_message>
<xml_diff>
--- a/deliverables/deck/ZeroCloud_SIH26119_NIRNAY.pptx
+++ b/deliverables/deck/ZeroCloud_SIH26119_NIRNAY.pptx
@@ -2245,6 +2245,17 @@
             <a:pPr indent="0" marL="0">
               <a:buNone/>
             </a:pPr>
+            <a:r>
+              <a:rPr lang="en-US" sz="1700" dirty="0">
+                <a:solidFill>
+                  <a:srgbClr val="2B2F36"/>
+                </a:solidFill>
+                <a:latin typeface="Calibri" pitchFamily="34" charset="0"/>
+                <a:ea typeface="Calibri" pitchFamily="34" charset="-122"/>
+                <a:cs typeface="Calibri" pitchFamily="34" charset="-120"/>
+              </a:rPr>
+              <a:t>175338</a:t>
+            </a:r>
             <a:endParaRPr lang="en-US" sz="1700" dirty="0"/>
           </a:p>
         </p:txBody>

</xml_diff>